<commit_message>
docs(seminar): BAAR 덱을 원문 PDF 실측값으로 갱신
- Table 3 실측 가스/시간으로 성능 슬라이드 교체
- Fig 3~8 주장과 그 내부 불일치를 두 장으로 분리
- Acc(유효 집합) vs RCL(폐기 목록) 원문 이중 서술을 인용으로 명시
- 대조 근거로 논문 원문(CC BY) 저장소에 포함

Co-Authored-By: Claude Opus 5 (1M context) <noreply@anthropic.com>
Claude-Session: https://claude.ai/code/session_01UbctXXYFHic8h7puHJY8pe
</commit_message>
<xml_diff>
--- a/documents/260903_seminar_BAAR.pptx
+++ b/documents/260903_seminar_BAAR.pptx
@@ -37,6 +37,7 @@
     <p:sldId id="279" r:id="rId32"/>
     <p:sldId id="280" r:id="rId33"/>
     <p:sldId id="281" r:id="rId34"/>
+    <p:sldId id="282" r:id="rId35"/>
   </p:sldIdLst>
   <p:sldSz cx="12192000" cy="6858000"/>
   <p:notesSz cx="6735763" cy="9866313"/>
@@ -3763,21 +3764,42 @@
             <a:pPr/>
             <a:r>
               <a:rPr b="1"/>
-              <a:t>비용 (원문)</a:t>
+              <a:t>원문은 폐기를 세 연산으로 나눈다 — 우리 계정 층과 대응된다</a:t>
             </a:r>
           </a:p>
           <a:p>
             <a:pPr lvl="1"/>
             <a:r>
               <a:rPr b="0"/>
-              <a:t>O(log n) 해시 연산, 폐기 가스 약 30K</a:t>
+              <a:t>Deactivate(식별자를 RCL에 추가) · Revoke(RCL 갱신) · Recover(재발급). 우리의 disabled / 크레덴셜 폐기 / unpin과 같은 삼분이다</a:t>
             </a:r>
           </a:p>
           <a:p>
             <a:pPr lvl="1"/>
             <a:r>
               <a:rPr b="0"/>
-              <a:t>폐기 지연: 뒤의 두 수치(≈180 ms / 200–310 ms)가 무엇을 잰 것인지 19번에서 따진다</a:t>
+              <a:t>Table 3 실측 가스: Revocation 31,238 · Deactivation 50,753 · Recovery 28,810 · Verify 28,083</a:t>
+            </a:r>
+          </a:p>
+          <a:p>
+            <a:pPr/>
+            <a:r>
+              <a:rPr b="1"/>
+              <a:t>복잡도와 지연 (원문)</a:t>
+            </a:r>
+          </a:p>
+          <a:p>
+            <a:pPr lvl="1"/>
+            <a:r>
+              <a:rPr b="0"/>
+              <a:t>Table 4: Revocation = O(d)H (d = 트리 깊이)</a:t>
+            </a:r>
+          </a:p>
+          <a:p>
+            <a:pPr lvl="1"/>
+            <a:r>
+              <a:rPr b="0"/>
+              <a:t>시간은 세 값이 따로 나온다(Table 3 0.0182 s, Fig 3 ≈180 ms, Fig 6 200→310 ms) — 20번에서 따진다</a:t>
             </a:r>
           </a:p>
           <a:p>
@@ -3798,7 +3820,7 @@
             <a:pPr/>
             <a:r>
               <a:rPr b="1"/>
-              <a:t>발표자 분석: 제거 즉시 효력이 생긴다. 유예 창이 없다 — 이 점은 우리보다 낫다(25번)</a:t>
+              <a:t>발표자 분석: 제거 즉시 효력이 생긴다. 유예 창이 없다 — 이 점은 우리보다 낫다(26번)</a:t>
             </a:r>
           </a:p>
         </p:txBody>
@@ -4174,7 +4196,7 @@
             </a:pPr>
             <a:r>
               <a:rPr b="0" sz="1200"/>
-              <a:t>원문 확인: accumulator는 "유효 크레덴셜의 root"로 정의되고, 인증은 VerifyMembership(R, C, W_C) = 1이다.</a:t>
+              <a:t>원문 Protocol 3: "Leaves form a Merkle tree with a root Acc, representing all valid credentials. To revoke, the CIA removes x and publishes Acc′ = MerkleRoot(X ∖ {x})", 인증은 MerkleVerify(Acc′, x, π) = 1 — 유효 집합 멤버십이다.</a:t>
             </a:r>
           </a:p>
           <a:p>
@@ -4183,7 +4205,7 @@
             </a:pPr>
             <a:r>
               <a:rPr b="0" sz="1200"/>
-              <a:t>다만 원문 안에서 서술이 엇갈린다 — revocation 트리거를 "식별자를 revocation 리스트에 추가"로 적은 대목이 있다. 정의·프로토콜·Lemma 5는 모두 '제거' 쪽과 일관되므로 그쪽을 취한다.</a:t>
+              <a:t>그런데 같은 논문의 알고리즘 명세는 다른 자료구조를 쓴다: RCL = "on-chain Revoked Credential List"(초기값 ∅), Deactivate/Revoke는 "adding its identifier to the revocation list". 이름도 방향도 반대인 둘이 공존한다.</a:t>
             </a:r>
           </a:p>
           <a:p>
@@ -4192,7 +4214,7 @@
             </a:pPr>
             <a:r>
               <a:rPr b="0" sz="1200"/>
-              <a:t>내부 문서 정정 필요: documents/260818_related_work...md의 §3.1 "zk-creds vs BAAR" 표와 §3.3 트리거 항목이 BAAR를 폐기 목록 기반으로 적고 있다.</a:t>
+              <a:t>발표자 판단: 인증식이 Acc를 쓰므로 실제 프로토콜은 멤버십이다. RCL은 표기만 남고 프로토콜·증명에 쓰이지 않는다 — 우리 내부 문서(§3.1 표·§3.3 트리거)가 이 RCL 쪽 서술을 받아 적어 반대로 정리돼 있다.</a:t>
             </a:r>
           </a:p>
         </p:txBody>
@@ -4619,7 +4641,7 @@
             </a:pPr>
             <a:r>
               <a:rPr b="0" sz="1200"/>
-              <a:t>대신 root가 바뀌는 빈도가 다르다: BAAR는 발급+폐기, 우리는 폐기만. 22번에서 이 손익분기를 본다.</a:t>
+              <a:t>대신 root가 바뀌는 빈도가 다르다: BAAR는 발급+폐기, 우리는 폐기만. 23번에서 이 손익분기를 본다.</a:t>
             </a:r>
           </a:p>
         </p:txBody>
@@ -5250,7 +5272,7 @@
           <a:lstStyle/>
           <a:p>
             <a:r>
-              <a:t>성능 ① 시간과 가스 (원문)</a:t>
+              <a:t>성능 ① 논문의 온체인 실측 (원문 Table 3)</a:t>
             </a:r>
           </a:p>
         </p:txBody>
@@ -5265,7 +5287,7 @@
         </p:nvGraphicFramePr>
         <p:xfrm>
           <a:off x="457200" y="1371600"/>
-          <a:ext cx="11247120" cy="2743200"/>
+          <a:ext cx="11247120" cy="3108960"/>
         </p:xfrm>
         <a:graphic>
           <a:graphicData uri="http://schemas.openxmlformats.org/drawingml/2006/table">
@@ -5274,13 +5296,11 @@
                 <a:tableStyleId>{5C22544A-7EE6-4342-B048-85BDC9FD1C3A}</a:tableStyleId>
               </a:tblPr>
               <a:tblGrid>
-                <a:gridCol w="2377440"/>
-                <a:gridCol w="2011680"/>
-                <a:gridCol w="2011680"/>
-                <a:gridCol w="2011680"/>
-                <a:gridCol w="2834640"/>
+                <a:gridCol w="3657600"/>
+                <a:gridCol w="3657600"/>
+                <a:gridCol w="3931920"/>
               </a:tblGrid>
-              <a:tr h="457200">
+              <a:tr h="444137">
                 <a:tc>
                   <a:txBody>
                     <a:bodyPr wrap="square"/>
@@ -5299,7 +5319,7 @@
                             <a:srgbClr val="FFFFFF"/>
                           </a:solidFill>
                         </a:rPr>
-                        <a:t>항목</a:t>
+                        <a:t>연산</a:t>
                       </a:r>
                     </a:p>
                   </a:txBody>
@@ -5327,7 +5347,7 @@
                             <a:srgbClr val="FFFFFF"/>
                           </a:solidFill>
                         </a:rPr>
-                        <a:t>BAAR</a:t>
+                        <a:t>Gas</a:t>
                       </a:r>
                     </a:p>
                   </a:txBody>
@@ -5355,7 +5375,7 @@
                             <a:srgbClr val="FFFFFF"/>
                           </a:solidFill>
                         </a:rPr>
-                        <a:t>비교군 [36]</a:t>
+                        <a:t>Transaction time (s)</a:t>
                       </a:r>
                     </a:p>
                   </a:txBody>
@@ -5365,64 +5385,8 @@
                     </a:solidFill>
                   </a:tcPr>
                 </a:tc>
-                <a:tc>
-                  <a:txBody>
-                    <a:bodyPr wrap="square"/>
-                    <a:lstStyle/>
-                    <a:p>
-                      <a:pPr>
-                        <a:defRPr sz="1300" b="1">
-                          <a:solidFill>
-                            <a:srgbClr val="FFFFFF"/>
-                          </a:solidFill>
-                        </a:defRPr>
-                      </a:pPr>
-                      <a:r>
-                        <a:rPr sz="1300" b="1">
-                          <a:solidFill>
-                            <a:srgbClr val="FFFFFF"/>
-                          </a:solidFill>
-                        </a:rPr>
-                        <a:t>비교군 [37]</a:t>
-                      </a:r>
-                    </a:p>
-                  </a:txBody>
-                  <a:tcPr anchor="ctr">
-                    <a:solidFill>
-                      <a:srgbClr val="44546A"/>
-                    </a:solidFill>
-                  </a:tcPr>
-                </a:tc>
-                <a:tc>
-                  <a:txBody>
-                    <a:bodyPr wrap="square"/>
-                    <a:lstStyle/>
-                    <a:p>
-                      <a:pPr>
-                        <a:defRPr sz="1300" b="1">
-                          <a:solidFill>
-                            <a:srgbClr val="FFFFFF"/>
-                          </a:solidFill>
-                        </a:defRPr>
-                      </a:pPr>
-                      <a:r>
-                        <a:rPr sz="1300" b="1">
-                          <a:solidFill>
-                            <a:srgbClr val="FFFFFF"/>
-                          </a:solidFill>
-                        </a:rPr>
-                        <a:t>가스</a:t>
-                      </a:r>
-                    </a:p>
-                  </a:txBody>
-                  <a:tcPr anchor="ctr">
-                    <a:solidFill>
-                      <a:srgbClr val="44546A"/>
-                    </a:solidFill>
-                  </a:tcPr>
-                </a:tc>
               </a:tr>
-              <a:tr h="457200">
+              <a:tr h="444137">
                 <a:tc>
                   <a:txBody>
                     <a:bodyPr wrap="square"/>
@@ -5449,7 +5413,7 @@
                       </a:pPr>
                       <a:r>
                         <a:rPr sz="1300"/>
-                        <a:t>~120 ms</a:t>
+                        <a:t>N/A</a:t>
                       </a:r>
                     </a:p>
                   </a:txBody>
@@ -5465,12 +5429,14 @@
                       </a:pPr>
                       <a:r>
                         <a:rPr sz="1300"/>
-                        <a:t>~190</a:t>
+                        <a:t>0.0001</a:t>
                       </a:r>
                     </a:p>
                   </a:txBody>
                   <a:tcPr anchor="ctr"/>
                 </a:tc>
+              </a:tr>
+              <a:tr h="444137">
                 <a:tc>
                   <a:txBody>
                     <a:bodyPr wrap="square"/>
@@ -5481,7 +5447,7 @@
                       </a:pPr>
                       <a:r>
                         <a:rPr sz="1300"/>
-                        <a:t>~160</a:t>
+                        <a:t>Verify</a:t>
                       </a:r>
                     </a:p>
                   </a:txBody>
@@ -5497,14 +5463,30 @@
                       </a:pPr>
                       <a:r>
                         <a:rPr sz="1300"/>
-                        <a:t>—</a:t>
+                        <a:t>28,083</a:t>
                       </a:r>
                     </a:p>
                   </a:txBody>
                   <a:tcPr anchor="ctr"/>
                 </a:tc>
+                <a:tc>
+                  <a:txBody>
+                    <a:bodyPr wrap="square"/>
+                    <a:lstStyle/>
+                    <a:p>
+                      <a:pPr>
+                        <a:defRPr sz="1300"/>
+                      </a:pPr>
+                      <a:r>
+                        <a:rPr sz="1300"/>
+                        <a:t>0.0549</a:t>
+                      </a:r>
+                    </a:p>
+                  </a:txBody>
+                  <a:tcPr anchor="ctr"/>
+                </a:tc>
               </a:tr>
-              <a:tr h="457200">
+              <a:tr h="444137">
                 <a:tc>
                   <a:txBody>
                     <a:bodyPr wrap="square"/>
@@ -5515,7 +5497,7 @@
                       </a:pPr>
                       <a:r>
                         <a:rPr sz="1300"/>
-                        <a:t>Key generation</a:t>
+                        <a:t>Validation</a:t>
                       </a:r>
                     </a:p>
                   </a:txBody>
@@ -5531,7 +5513,7 @@
                       </a:pPr>
                       <a:r>
                         <a:rPr sz="1300"/>
-                        <a:t>~150 ms</a:t>
+                        <a:t>28,083</a:t>
                       </a:r>
                     </a:p>
                   </a:txBody>
@@ -5547,12 +5529,14 @@
                       </a:pPr>
                       <a:r>
                         <a:rPr sz="1300"/>
-                        <a:t>~230</a:t>
+                        <a:t>0.0669</a:t>
                       </a:r>
                     </a:p>
                   </a:txBody>
                   <a:tcPr anchor="ctr"/>
                 </a:tc>
+              </a:tr>
+              <a:tr h="444137">
                 <a:tc>
                   <a:txBody>
                     <a:bodyPr wrap="square"/>
@@ -5563,7 +5547,7 @@
                       </a:pPr>
                       <a:r>
                         <a:rPr sz="1300"/>
-                        <a:t>~210</a:t>
+                        <a:t>Deactivation</a:t>
                       </a:r>
                     </a:p>
                   </a:txBody>
@@ -5579,14 +5563,80 @@
                       </a:pPr>
                       <a:r>
                         <a:rPr sz="1300"/>
-                        <a:t>—</a:t>
+                        <a:t>50,753</a:t>
                       </a:r>
                     </a:p>
                   </a:txBody>
                   <a:tcPr anchor="ctr"/>
                 </a:tc>
+                <a:tc>
+                  <a:txBody>
+                    <a:bodyPr wrap="square"/>
+                    <a:lstStyle/>
+                    <a:p>
+                      <a:pPr>
+                        <a:defRPr sz="1300"/>
+                      </a:pPr>
+                      <a:r>
+                        <a:rPr sz="1300"/>
+                        <a:t>0.0883</a:t>
+                      </a:r>
+                    </a:p>
+                  </a:txBody>
+                  <a:tcPr anchor="ctr"/>
+                </a:tc>
               </a:tr>
-              <a:tr h="457200">
+              <a:tr h="444137">
+                <a:tc>
+                  <a:txBody>
+                    <a:bodyPr wrap="square"/>
+                    <a:lstStyle/>
+                    <a:p>
+                      <a:pPr>
+                        <a:defRPr sz="1300"/>
+                      </a:pPr>
+                      <a:r>
+                        <a:rPr sz="1300"/>
+                        <a:t>Recovery</a:t>
+                      </a:r>
+                    </a:p>
+                  </a:txBody>
+                  <a:tcPr anchor="ctr"/>
+                </a:tc>
+                <a:tc>
+                  <a:txBody>
+                    <a:bodyPr wrap="square"/>
+                    <a:lstStyle/>
+                    <a:p>
+                      <a:pPr>
+                        <a:defRPr sz="1300"/>
+                      </a:pPr>
+                      <a:r>
+                        <a:rPr sz="1300"/>
+                        <a:t>28,810</a:t>
+                      </a:r>
+                    </a:p>
+                  </a:txBody>
+                  <a:tcPr anchor="ctr"/>
+                </a:tc>
+                <a:tc>
+                  <a:txBody>
+                    <a:bodyPr wrap="square"/>
+                    <a:lstStyle/>
+                    <a:p>
+                      <a:pPr>
+                        <a:defRPr sz="1300"/>
+                      </a:pPr>
+                      <a:r>
+                        <a:rPr sz="1300"/>
+                        <a:t>0.1109</a:t>
+                      </a:r>
+                    </a:p>
+                  </a:txBody>
+                  <a:tcPr anchor="ctr"/>
+                </a:tc>
+              </a:tr>
+              <a:tr h="444138">
                 <a:tc>
                   <a:txBody>
                     <a:bodyPr wrap="square"/>
@@ -5613,7 +5663,7 @@
                       </a:pPr>
                       <a:r>
                         <a:rPr sz="1300"/>
-                        <a:t>~180 ms</a:t>
+                        <a:t>31,238</a:t>
                       </a:r>
                     </a:p>
                   </a:txBody>
@@ -5629,203 +5679,7 @@
                       </a:pPr>
                       <a:r>
                         <a:rPr sz="1300"/>
-                        <a:t>~280</a:t>
-                      </a:r>
-                    </a:p>
-                  </a:txBody>
-                  <a:tcPr anchor="ctr"/>
-                </a:tc>
-                <a:tc>
-                  <a:txBody>
-                    <a:bodyPr wrap="square"/>
-                    <a:lstStyle/>
-                    <a:p>
-                      <a:pPr>
-                        <a:defRPr sz="1300"/>
-                      </a:pPr>
-                      <a:r>
-                        <a:rPr sz="1300"/>
-                        <a:t>~250</a:t>
-                      </a:r>
-                    </a:p>
-                  </a:txBody>
-                  <a:tcPr anchor="ctr"/>
-                </a:tc>
-                <a:tc>
-                  <a:txBody>
-                    <a:bodyPr wrap="square"/>
-                    <a:lstStyle/>
-                    <a:p>
-                      <a:pPr>
-                        <a:defRPr sz="1300"/>
-                      </a:pPr>
-                      <a:r>
-                        <a:rPr sz="1300"/>
-                        <a:t>~30K (vs [37] ~270K)</a:t>
-                      </a:r>
-                    </a:p>
-                  </a:txBody>
-                  <a:tcPr anchor="ctr"/>
-                </a:tc>
-              </a:tr>
-              <a:tr h="457200">
-                <a:tc>
-                  <a:txBody>
-                    <a:bodyPr wrap="square"/>
-                    <a:lstStyle/>
-                    <a:p>
-                      <a:pPr>
-                        <a:defRPr sz="1300"/>
-                      </a:pPr>
-                      <a:r>
-                        <a:rPr sz="1300"/>
-                        <a:t>Verification</a:t>
-                      </a:r>
-                    </a:p>
-                  </a:txBody>
-                  <a:tcPr anchor="ctr"/>
-                </a:tc>
-                <a:tc>
-                  <a:txBody>
-                    <a:bodyPr wrap="square"/>
-                    <a:lstStyle/>
-                    <a:p>
-                      <a:pPr>
-                        <a:defRPr sz="1300"/>
-                      </a:pPr>
-                      <a:r>
-                        <a:rPr sz="1300"/>
-                        <a:t>~200 ms</a:t>
-                      </a:r>
-                    </a:p>
-                  </a:txBody>
-                  <a:tcPr anchor="ctr"/>
-                </a:tc>
-                <a:tc>
-                  <a:txBody>
-                    <a:bodyPr wrap="square"/>
-                    <a:lstStyle/>
-                    <a:p>
-                      <a:pPr>
-                        <a:defRPr sz="1300"/>
-                      </a:pPr>
-                      <a:r>
-                        <a:rPr sz="1300"/>
-                        <a:t>~350</a:t>
-                      </a:r>
-                    </a:p>
-                  </a:txBody>
-                  <a:tcPr anchor="ctr"/>
-                </a:tc>
-                <a:tc>
-                  <a:txBody>
-                    <a:bodyPr wrap="square"/>
-                    <a:lstStyle/>
-                    <a:p>
-                      <a:pPr>
-                        <a:defRPr sz="1300"/>
-                      </a:pPr>
-                      <a:r>
-                        <a:rPr sz="1300"/>
-                        <a:t>~320</a:t>
-                      </a:r>
-                    </a:p>
-                  </a:txBody>
-                  <a:tcPr anchor="ctr"/>
-                </a:tc>
-                <a:tc>
-                  <a:txBody>
-                    <a:bodyPr wrap="square"/>
-                    <a:lstStyle/>
-                    <a:p>
-                      <a:pPr>
-                        <a:defRPr sz="1300"/>
-                      </a:pPr>
-                      <a:r>
-                        <a:rPr sz="1300"/>
-                        <a:t>~60K (vs [37] ~100K)</a:t>
-                      </a:r>
-                    </a:p>
-                  </a:txBody>
-                  <a:tcPr anchor="ctr"/>
-                </a:tc>
-              </a:tr>
-              <a:tr h="457200">
-                <a:tc>
-                  <a:txBody>
-                    <a:bodyPr wrap="square"/>
-                    <a:lstStyle/>
-                    <a:p>
-                      <a:pPr>
-                        <a:defRPr sz="1300"/>
-                      </a:pPr>
-                      <a:r>
-                        <a:rPr sz="1300"/>
-                        <a:t>Create</a:t>
-                      </a:r>
-                    </a:p>
-                  </a:txBody>
-                  <a:tcPr anchor="ctr"/>
-                </a:tc>
-                <a:tc>
-                  <a:txBody>
-                    <a:bodyPr wrap="square"/>
-                    <a:lstStyle/>
-                    <a:p>
-                      <a:pPr>
-                        <a:defRPr sz="1300"/>
-                      </a:pPr>
-                      <a:r>
-                        <a:rPr sz="1300"/>
-                        <a:t>—</a:t>
-                      </a:r>
-                    </a:p>
-                  </a:txBody>
-                  <a:tcPr anchor="ctr"/>
-                </a:tc>
-                <a:tc>
-                  <a:txBody>
-                    <a:bodyPr wrap="square"/>
-                    <a:lstStyle/>
-                    <a:p>
-                      <a:pPr>
-                        <a:defRPr sz="1300"/>
-                      </a:pPr>
-                      <a:r>
-                        <a:rPr sz="1300"/>
-                        <a:t>—</a:t>
-                      </a:r>
-                    </a:p>
-                  </a:txBody>
-                  <a:tcPr anchor="ctr"/>
-                </a:tc>
-                <a:tc>
-                  <a:txBody>
-                    <a:bodyPr wrap="square"/>
-                    <a:lstStyle/>
-                    <a:p>
-                      <a:pPr>
-                        <a:defRPr sz="1300"/>
-                      </a:pPr>
-                      <a:r>
-                        <a:rPr sz="1300"/>
-                        <a:t>—</a:t>
-                      </a:r>
-                    </a:p>
-                  </a:txBody>
-                  <a:tcPr anchor="ctr"/>
-                </a:tc>
-                <a:tc>
-                  <a:txBody>
-                    <a:bodyPr wrap="square"/>
-                    <a:lstStyle/>
-                    <a:p>
-                      <a:pPr>
-                        <a:defRPr sz="1300"/>
-                      </a:pPr>
-                      <a:r>
-                        <a:rPr sz="1300"/>
-                        <a:t>~110K (vs [37] ~135K)</a:t>
+                        <a:t>0.0182</a:t>
                       </a:r>
                     </a:p>
                   </a:txBody>
@@ -5863,16 +5717,7 @@
             </a:pPr>
             <a:r>
               <a:rPr b="0" sz="1200"/>
-              <a:t>논문은 시간 25~50% 개선, 폐기 가스 약 88% 감소를 주장한다.</a:t>
-            </a:r>
-          </a:p>
-          <a:p>
-            <a:pPr>
-              <a:defRPr sz="1200"/>
-            </a:pPr>
-            <a:r>
-              <a:rPr b="0" sz="1200"/>
-              <a:t>발표자 분석: 폐기 가스가 낮은 이유는 온체인에 root 하나만 올리기 때문이다 — 목록을 올리지 않는다. 우리 구조도 온체인 상태는 root 32바이트다.</a:t>
+              <a:t>이것이 논문 자신의 측정표다. 뒤의 비교 그림(Fig 3·4)과 값이 어긋나는 대목이 있어 20번에서 따진다.</a:t>
             </a:r>
           </a:p>
         </p:txBody>
@@ -5911,7 +5756,7 @@
           <a:lstStyle/>
           <a:p>
             <a:r>
-              <a:t>성능 ② 확장성 주장과, 그 안의 불일치</a:t>
+              <a:t>성능 ② 비교 그림이 말하는 것 (원문 Fig 3·4·5·6·8)</a:t>
             </a:r>
           </a:p>
         </p:txBody>
@@ -5934,77 +5779,63 @@
             <a:pPr/>
             <a:r>
               <a:rPr b="1"/>
-              <a:t>폐기 확장성 (원문)</a:t>
+              <a:t>시간 (Fig 3, 비교군 [36]·[37])</a:t>
             </a:r>
           </a:p>
           <a:p>
             <a:pPr lvl="1"/>
             <a:r>
               <a:rPr b="0"/>
-              <a:t>건당 폐기 지연이 규모에 거의 일정하다는 주장 — 200 ms → 310 ms(5,000건 구간)</a:t>
-            </a:r>
-          </a:p>
-          <a:p>
-            <a:pPr lvl="1"/>
+              <a:t>Setup 120 / 190 / 160 ms · KeyGen 150 / 23 / 210 ms · Revocation 180 / 280 / 250 ms · Verification 200 / 350 / 320s</a:t>
+            </a:r>
+          </a:p>
+          <a:p>
+            <a:pPr/>
             <a:r>
               <a:rPr b="1"/>
-              <a:t>그런데 앞 장 표는 Revocation을 ~180 ms로 적는다 — 두 값이 무엇을 잰 것인지 논문에 구분이 없다</a:t>
+              <a:t>가스 (Fig 4, 비교군 [37])</a:t>
             </a:r>
           </a:p>
           <a:p>
             <a:pPr lvl="1"/>
             <a:r>
               <a:rPr b="0"/>
-              <a:t>비교군 수치도 "[14] 5,000건에서 약 5초"와 "800–950 ms에서 안정화"가 나란히 나와 대상이 불분명하다</a:t>
+              <a:t>Create ≈110K vs ≈135K · Verify ≈60K vs ≈100K · Revocation ≈30K vs ≈270K. "가스 50~90% 절감" 주장</a:t>
             </a:r>
           </a:p>
           <a:p>
             <a:pPr/>
             <a:r>
               <a:rPr b="1"/>
-              <a:t>속성 확장성 (원문)</a:t>
+              <a:t>폐기 확장성 (Fig 5·6, 비교군 [14]) — 논문은 "two mutually valid dimensions"라 부른다</a:t>
             </a:r>
           </a:p>
           <a:p>
             <a:pPr lvl="1"/>
             <a:r>
               <a:rPr b="0"/>
-              <a:t>속성 8~1024개에서 검증 시간 약 15–20 ms로 "sublinear"</a:t>
+              <a:t>Fig 5 누적: [14]는 5,000건에서 약 5초로 선형, BAAR는 "remains constant nonetheless of the number"</a:t>
             </a:r>
           </a:p>
           <a:p>
             <a:pPr lvl="1"/>
             <a:r>
               <a:rPr b="0"/>
-              <a:t>비교군 [15]은 15초 → 33초</a:t>
+              <a:t>Fig 6 건당: [14]는 800–950 ms에서 안정화, BAAR는 200 ms → 310 ms(5,000건)</a:t>
             </a:r>
           </a:p>
           <a:p>
             <a:pPr/>
             <a:r>
               <a:rPr b="1"/>
-              <a:t>발표자 분석 — 여기가 이 논문에서 가장 약한 부분이다</a:t>
+              <a:t>속성 확장성 (Fig 7·8, 비교군 [15])</a:t>
             </a:r>
           </a:p>
           <a:p>
             <a:pPr lvl="1"/>
             <a:r>
               <a:rPr b="0"/>
-              <a:t>① 같은 논문의 Table 4가 인증을 O(n) EC 곱셈으로 적는다. Pedersen/Schnorr PoK는 생성원 n개에 대한 곱셈이 필수라 n에 선형이어야 한다</a:t>
-            </a:r>
-          </a:p>
-          <a:p>
-            <a:pPr lvl="1"/>
-            <a:r>
-              <a:rPr b="0"/>
-              <a:t>② 비교군 [15]의 15초→33초를 "선형 증가"라 부르는데, 속성 128배에 2.2배면 선형이 아니라 강한 sublinear다</a:t>
-            </a:r>
-          </a:p>
-          <a:p>
-            <a:pPr lvl="1"/>
-            <a:r>
-              <a:rPr b="0"/>
-              <a:t>③ 15초는 SNARK 검증 시간일 수 없다(증명 생성 시간이다). 검증 시간과 나란히 놓으면 부당 비교다</a:t>
+              <a:t>Fig 7 validation: BAAR 0.018 s vs [15] 0.028 s. Fig 8: 속성 8~1024에서 [15]는 15초 → 33초, BAAR는 "sublinear and stable"</a:t>
             </a:r>
           </a:p>
         </p:txBody>
@@ -6108,14 +5939,14 @@
             <a:pPr lvl="1"/>
             <a:r>
               <a:rPr b="0"/>
-              <a:t>⑥ 평가와 수치, 그리고 그 안의 모순 (17~19)</a:t>
+              <a:t>⑥ 평가와 수치, 그리고 그 안의 모순 (17~20)</a:t>
             </a:r>
           </a:p>
           <a:p>
             <a:pPr lvl="1"/>
             <a:r>
               <a:rPr b="0"/>
-              <a:t>⑦ 비판적 검토와 우리 설계와의 대조 (20~26)</a:t>
+              <a:t>⑦ 비판적 검토와 우리 설계와의 대조 (21~27)</a:t>
             </a:r>
           </a:p>
           <a:p>
@@ -6129,7 +5960,7 @@
             <a:pPr lvl="1"/>
             <a:r>
               <a:rPr b="0"/>
-              <a:t>"원문": 논문 본문에 있는 내용</a:t>
+              <a:t>"원문": 논문 본문에 있는 내용 — documents/BAAR_PLOSONE_e0343696.pdf로 직접 대조했다</a:t>
             </a:r>
           </a:p>
           <a:p>
@@ -6164,7 +5995,7 @@
             <a:pPr lvl="1"/>
             <a:r>
               <a:rPr b="0"/>
-              <a:t>13~14번(핵심 선택)까지를 25분 지점 통과 목표로, 20~26번(비판·대조)에 최소 25분을 남긴다</a:t>
+              <a:t>13~14번(핵심 선택)까지를 25분 지점 통과 목표로, 21~27번(비판·대조)에 최소 25분을 남긴다</a:t>
             </a:r>
           </a:p>
         </p:txBody>
@@ -6178,6 +6009,145 @@
 </file>
 
 <file path=ppt/slides/slide20.xml><?xml version="1.0" encoding="utf-8"?>
+<p:sld xmlns:a="http://schemas.openxmlformats.org/drawingml/2006/main" xmlns:p="http://schemas.openxmlformats.org/presentationml/2006/main" xmlns:r="http://schemas.openxmlformats.org/officeDocument/2006/relationships">
+  <p:cSld>
+    <p:spTree>
+      <p:nvGrpSpPr>
+        <p:cNvPr id="1" name=""/>
+        <p:cNvGrpSpPr/>
+        <p:nvPr/>
+      </p:nvGrpSpPr>
+      <p:grpSpPr/>
+      <p:sp>
+        <p:nvSpPr>
+          <p:cNvPr id="2" name="Title 1"/>
+          <p:cNvSpPr>
+            <a:spLocks noGrp="1"/>
+          </p:cNvSpPr>
+          <p:nvPr>
+            <p:ph type="title"/>
+          </p:nvPr>
+        </p:nvSpPr>
+        <p:spPr/>
+        <p:txBody>
+          <a:bodyPr/>
+          <a:lstStyle/>
+          <a:p>
+            <a:r>
+              <a:t>성능 ③ 그 수치들이 서로 맞지 않는다 (발표자 분석)</a:t>
+            </a:r>
+          </a:p>
+        </p:txBody>
+      </p:sp>
+      <p:sp>
+        <p:nvSpPr>
+          <p:cNvPr id="3" name="Content Placeholder 2"/>
+          <p:cNvSpPr>
+            <a:spLocks noGrp="1"/>
+          </p:cNvSpPr>
+          <p:nvPr>
+            <p:ph idx="1"/>
+          </p:nvPr>
+        </p:nvSpPr>
+        <p:spPr/>
+        <p:txBody>
+          <a:bodyPr/>
+          <a:lstStyle/>
+          <a:p>
+            <a:pPr/>
+            <a:r>
+              <a:rPr b="1"/>
+              <a:t>① 같은 연산에 값이 둘씩 있다</a:t>
+            </a:r>
+          </a:p>
+          <a:p>
+            <a:pPr lvl="1"/>
+            <a:r>
+              <a:rPr b="0"/>
+              <a:t>Verify 가스: Table 3은 28,083인데 Fig 4는 ≈60K — 2배 차이다</a:t>
+            </a:r>
+          </a:p>
+          <a:p>
+            <a:pPr lvl="1"/>
+            <a:r>
+              <a:rPr b="0"/>
+              <a:t>Validation 시간: Table 3은 0.0669 s인데 Fig 7은 0.018 s</a:t>
+            </a:r>
+          </a:p>
+          <a:p>
+            <a:pPr lvl="1"/>
+            <a:r>
+              <a:rPr b="0"/>
+              <a:t>Revocation 시간: Table 3 0.0182 s · Fig 3 ≈180 ms · Fig 6 200~310 ms — 셋 다 다르고 정의가 없다</a:t>
+            </a:r>
+          </a:p>
+          <a:p>
+            <a:pPr/>
+            <a:r>
+              <a:rPr b="1"/>
+              <a:t>② Fig 5와 Fig 6이 동시에 참일 수 없다</a:t>
+            </a:r>
+          </a:p>
+          <a:p>
+            <a:pPr lvl="1"/>
+            <a:r>
+              <a:rPr b="0"/>
+              <a:t>건당 지연이 200 → 310 ms로 오르는데 누적이 "일정"할 수는 없다. 누적은 건당의 합이다</a:t>
+            </a:r>
+          </a:p>
+          <a:p>
+            <a:pPr/>
+            <a:r>
+              <a:rPr b="1"/>
+              <a:t>③ 우월성 서술이 자기 수치와 어긋난다</a:t>
+            </a:r>
+          </a:p>
+          <a:p>
+            <a:pPr lvl="1"/>
+            <a:r>
+              <a:rPr b="0"/>
+              <a:t>KeyGen에서 [36]은 23 ms인데 BAAR는 150 ms다. 논문은 그런데도 "BAAR also exhibits superior efficiency"라고 적는다(6.5배 느리다)</a:t>
+            </a:r>
+          </a:p>
+          <a:p>
+            <a:pPr lvl="1"/>
+            <a:r>
+              <a:rPr b="0"/>
+              <a:t>Verification 비교의 "320s"는 단위 오류로 보인다(320 ms). Fig 7 서술의 "36 percent higher"도 실제로는 낮은 값이다</a:t>
+            </a:r>
+          </a:p>
+          <a:p>
+            <a:pPr/>
+            <a:r>
+              <a:rPr b="1"/>
+              <a:t>④ sublinear 주장이 자기 복잡도 표와 충돌한다</a:t>
+            </a:r>
+          </a:p>
+          <a:p>
+            <a:pPr lvl="1"/>
+            <a:r>
+              <a:rPr b="0"/>
+              <a:t>Table 4: Authentication = ((m+3)SM + 2PA + (d+2)H + S) — 속성 수 m에 선형이다(SM = scalar multiplication)</a:t>
+            </a:r>
+          </a:p>
+          <a:p>
+            <a:pPr lvl="1"/>
+            <a:r>
+              <a:rPr b="0"/>
+              <a:t>그리고 [15]의 15→33초는 논문 스스로 "inherent SNARK generation"에 귀속한다 — 증명 생성 시간을 BAAR의 검증 시간과 나란히 놓은 것이다</a:t>
+            </a:r>
+          </a:p>
+        </p:txBody>
+      </p:sp>
+    </p:spTree>
+  </p:cSld>
+  <p:clrMapOvr>
+    <a:masterClrMapping/>
+  </p:clrMapOvr>
+</p:sld>
+</file>
+
+<file path=ppt/slides/slide21.xml><?xml version="1.0" encoding="utf-8"?>
 <p:sld xmlns:a="http://schemas.openxmlformats.org/drawingml/2006/main" xmlns:p="http://schemas.openxmlformats.org/presentationml/2006/main" xmlns:r="http://schemas.openxmlformats.org/officeDocument/2006/relationships">
   <p:cSld>
     <p:spTree>
@@ -6925,117 +6895,6 @@
 </p:sld>
 </file>
 
-<file path=ppt/slides/slide21.xml><?xml version="1.0" encoding="utf-8"?>
-<p:sld xmlns:a="http://schemas.openxmlformats.org/drawingml/2006/main" xmlns:p="http://schemas.openxmlformats.org/presentationml/2006/main" xmlns:r="http://schemas.openxmlformats.org/officeDocument/2006/relationships">
-  <p:cSld>
-    <p:spTree>
-      <p:nvGrpSpPr>
-        <p:cNvPr id="1" name=""/>
-        <p:cNvGrpSpPr/>
-        <p:nvPr/>
-      </p:nvGrpSpPr>
-      <p:grpSpPr/>
-      <p:sp>
-        <p:nvSpPr>
-          <p:cNvPr id="2" name="Title 1"/>
-          <p:cNvSpPr>
-            <a:spLocks noGrp="1"/>
-          </p:cNvSpPr>
-          <p:nvPr>
-            <p:ph type="title"/>
-          </p:nvPr>
-        </p:nvSpPr>
-        <p:spPr/>
-        <p:txBody>
-          <a:bodyPr/>
-          <a:lstStyle/>
-          <a:p>
-            <a:r>
-              <a:t>비판 ① 진짜 문제는 계산량이 아니라 전달 채널이다</a:t>
-            </a:r>
-          </a:p>
-        </p:txBody>
-      </p:sp>
-      <p:sp>
-        <p:nvSpPr>
-          <p:cNvPr id="3" name="Content Placeholder 2"/>
-          <p:cNvSpPr>
-            <a:spLocks noGrp="1"/>
-          </p:cNvSpPr>
-          <p:nvPr>
-            <p:ph idx="1"/>
-          </p:nvPr>
-        </p:nvSpPr>
-        <p:spPr/>
-        <p:txBody>
-          <a:bodyPr/>
-          <a:lstStyle/>
-          <a:p>
-            <a:pPr/>
-            <a:r>
-              <a:rPr b="1"/>
-              <a:t>흔한 비판: "witness 갱신 비용이 평가에 없다" — 이것만으로는 약하다</a:t>
-            </a:r>
-          </a:p>
-          <a:p>
-            <a:pPr lvl="1"/>
-            <a:r>
-              <a:rPr b="0"/>
-              <a:t>우리 실측 1.97 ms는 지갑이 전체 리프 배열을 이미 들고 증분만 받는 전제의 값이다 — BAAR 사용자에게 없는 조건이다</a:t>
-            </a:r>
-          </a:p>
-          <a:p>
-            <a:pPr lvl="1"/>
-            <a:r>
-              <a:rPr b="0"/>
-              <a:t>로컬 상태가 없는 쪽에 가까운 값은 콜드 재구성이다: n=32,000에서 3,373 ms(우리 v2). 계산량만으로는 결정적이지 않다</a:t>
-            </a:r>
-          </a:p>
-          <a:p>
-            <a:pPr/>
-            <a:r>
-              <a:rPr b="1"/>
-              <a:t>버티는 축 — 누가 새 witness를 주는가 (발표자 분석)</a:t>
-            </a:r>
-          </a:p>
-          <a:p>
-            <a:pPr lvl="1"/>
-            <a:r>
-              <a:rPr b="0"/>
-              <a:t>원문은 개별 커밋먼트를 온체인에 저장하지 않고(8번), 오프체인 공개 채널도 명세하지 않는다 → 사용자가 자기 witness를 다시 만들 방법이 없다</a:t>
-            </a:r>
-          </a:p>
-          <a:p>
-            <a:pPr lvl="1"/>
-            <a:r>
-              <a:rPr b="1"/>
-              <a:t>원리적 한계는 아니다 — C는 perfectly hiding이라 CIA가 리프 목록을 공개해도 신원이 드러나지 않는다. 다만 논문에 그 설계가 없다</a:t>
-            </a:r>
-          </a:p>
-          <a:p>
-            <a:pPr lvl="1"/>
-            <a:r>
-              <a:rPr b="0"/>
-              <a:t>즉 갱신은 CIA에 의존한다 — 상시 가용성이 필요하고, 검열 지점이 되며,</a:t>
-            </a:r>
-          </a:p>
-          <a:p>
-            <a:pPr lvl="1"/>
-            <a:r>
-              <a:rPr b="1"/>
-              <a:t>"누가 언제 갱신을 요청했는가"가 CIA에게 그대로 남는다(익명성 주장과 정면으로 긴장한다)</a:t>
-            </a:r>
-          </a:p>
-        </p:txBody>
-      </p:sp>
-    </p:spTree>
-  </p:cSld>
-  <p:clrMapOvr>
-    <a:masterClrMapping/>
-  </p:clrMapOvr>
-</p:sld>
-</file>
-
 <file path=ppt/slides/slide22.xml><?xml version="1.0" encoding="utf-8"?>
 <p:sld xmlns:a="http://schemas.openxmlformats.org/drawingml/2006/main" xmlns:p="http://schemas.openxmlformats.org/presentationml/2006/main" xmlns:r="http://schemas.openxmlformats.org/officeDocument/2006/relationships">
   <p:cSld>
@@ -7062,7 +6921,7 @@
           <a:lstStyle/>
           <a:p>
             <a:r>
-              <a:t>비판 ② 손익분기 — 갱신 트래픽 대 회로 비용</a:t>
+              <a:t>비판 ① 진짜 문제는 계산량이 아니라 전달 채널이다</a:t>
             </a:r>
           </a:p>
         </p:txBody>
@@ -7085,84 +6944,56 @@
             <a:pPr/>
             <a:r>
               <a:rPr b="1"/>
-              <a:t>두 방식은 서로 다른 비용을 낸다. 한 축만 보면 손익분기가 없다 (발표자 분석)</a:t>
+              <a:t>흔한 비판: "witness 갱신 비용이 평가에 없다" — 이것만으로는 약하다</a:t>
             </a:r>
           </a:p>
           <a:p>
             <a:pPr lvl="1"/>
             <a:r>
               <a:rPr b="0"/>
-              <a:t>root 변경 빈도만 비교하면 λ_발급+λ_폐기(BAAR) ≥ λ_폐기(우리)라 우리가 항상 이긴다 — 그건 비교가 아니다</a:t>
+              <a:t>우리 실측 1.97 ms는 지갑이 전체 리프 배열을 이미 들고 증분만 받는 전제의 값이다 — BAAR 사용자에게 없는 조건이다</a:t>
+            </a:r>
+          </a:p>
+          <a:p>
+            <a:pPr lvl="1"/>
+            <a:r>
+              <a:rPr b="0"/>
+              <a:t>로컬 상태가 없는 쪽에 가까운 값은 콜드 재구성이다: n=32,000에서 3,373 ms(우리 v2). 계산량만으로는 결정적이지 않다</a:t>
             </a:r>
           </a:p>
           <a:p>
             <a:pPr/>
             <a:r>
               <a:rPr b="1"/>
-              <a:t>두 항으로 놓아야 갈림길이 보인다</a:t>
+              <a:t>버티는 축 — 누가 새 witness를 주는가 (발표자 분석)</a:t>
             </a:r>
           </a:p>
           <a:p>
             <a:pPr lvl="1"/>
             <a:r>
               <a:rPr b="0"/>
-              <a:t>BAAR가 더 내는 것:  (λ_발급 − λ_재기준화) × N_users × c_갱신   ← 폐기 게시는 양쪽 다 내므로 상쇄된다</a:t>
+              <a:t>원문은 개별 커밋먼트를 온체인에 저장하지 않고(8번), 오프체인 공개 채널도 명세하지 않는다 → 사용자가 자기 witness를 다시 만들 방법이 없다</a:t>
+            </a:r>
+          </a:p>
+          <a:p>
+            <a:pPr lvl="1"/>
+            <a:r>
+              <a:rPr b="1"/>
+              <a:t>원리적 한계는 아니다 — C는 perfectly hiding이라 CIA가 리프 목록을 공개해도 신원이 드러나지 않는다. 다만 논문에 그 설계가 없다</a:t>
             </a:r>
           </a:p>
           <a:p>
             <a:pPr lvl="1"/>
             <a:r>
               <a:rPr b="0"/>
-              <a:t>우리가 더 내는 것:  λ_인증 × Δc_회로                          ← 인증 1회마다 붙는 비멤버십 비용</a:t>
-            </a:r>
-          </a:p>
-          <a:p>
-            <a:pPr lvl="1"/>
-            <a:r>
-              <a:rPr b="0"/>
-              <a:t>두 항은 단위가 다르므로 같은 척도(예: 사용자·단위시간당 지갑 CPU ms)로 환산해 비교해야 한다</a:t>
-            </a:r>
-          </a:p>
-          <a:p>
-            <a:pPr lvl="1"/>
-            <a:r>
-              <a:rPr b="0"/>
-              <a:t>손익분기는 그렇게 환산한 두 값이 같아지는 지점이다. N이 크고 발급이 잦을수록 BAAR 쪽이 커진다</a:t>
-            </a:r>
-          </a:p>
-          <a:p>
-            <a:pPr/>
+              <a:t>즉 갱신은 CIA에 의존한다 — 상시 가용성이 필요하고, 검열 지점이 되며,</a:t>
+            </a:r>
+          </a:p>
+          <a:p>
+            <a:pPr lvl="1"/>
             <a:r>
               <a:rPr b="1"/>
-              <a:t>우리 쪽 항의 크기 (우리 실측)</a:t>
-            </a:r>
-          </a:p>
-          <a:p>
-            <a:pPr lvl="1"/>
-            <a:r>
-              <a:rPr b="0"/>
-              <a:t>비멤버십 검증 1개 = 6,648 constraints. pi_pk_i는 세션·계정 두 번 인스턴스화한다 → 13,296</a:t>
-            </a:r>
-          </a:p>
-          <a:p>
-            <a:pPr lvl="1"/>
-            <a:r>
-              <a:rPr b="0"/>
-              <a:t>전체 19,251 중 69%가 폐기 확인 비용이다</a:t>
-            </a:r>
-          </a:p>
-          <a:p>
-            <a:pPr lvl="1"/>
-            <a:r>
-              <a:rPr b="1"/>
-              <a:t>단 constraints 69%가 시간 69%는 아니다 — 4,820 → 19,251(4.0배)일 때 295.5 → 755.8 ms(2.56배)다. 19번에서 BAAR를 때린 논리를 우리도 지켜야 한다</a:t>
-            </a:r>
-          </a:p>
-          <a:p>
-            <a:pPr/>
-            <a:r>
-              <a:rPr b="1"/>
-              <a:t>그래서: 우리는 세션마다 발급하므로(λ_발급 ≫ λ_폐기) BAAR 방식이면 갱신이 상시로 흐른다. 반대로 발급이 드문 환경이라면 회로 69%를 아끼는 BAAR 쪽이 낫다</a:t>
+              <a:t>"누가 언제 갱신을 요청했는가"가 CIA에게 그대로 남는다(익명성 주장과 정면으로 긴장한다)</a:t>
             </a:r>
           </a:p>
         </p:txBody>
@@ -7176,6 +7007,145 @@
 </file>
 
 <file path=ppt/slides/slide23.xml><?xml version="1.0" encoding="utf-8"?>
+<p:sld xmlns:a="http://schemas.openxmlformats.org/drawingml/2006/main" xmlns:p="http://schemas.openxmlformats.org/presentationml/2006/main" xmlns:r="http://schemas.openxmlformats.org/officeDocument/2006/relationships">
+  <p:cSld>
+    <p:spTree>
+      <p:nvGrpSpPr>
+        <p:cNvPr id="1" name=""/>
+        <p:cNvGrpSpPr/>
+        <p:nvPr/>
+      </p:nvGrpSpPr>
+      <p:grpSpPr/>
+      <p:sp>
+        <p:nvSpPr>
+          <p:cNvPr id="2" name="Title 1"/>
+          <p:cNvSpPr>
+            <a:spLocks noGrp="1"/>
+          </p:cNvSpPr>
+          <p:nvPr>
+            <p:ph type="title"/>
+          </p:nvPr>
+        </p:nvSpPr>
+        <p:spPr/>
+        <p:txBody>
+          <a:bodyPr/>
+          <a:lstStyle/>
+          <a:p>
+            <a:r>
+              <a:t>비판 ② 손익분기 — 갱신 트래픽 대 회로 비용</a:t>
+            </a:r>
+          </a:p>
+        </p:txBody>
+      </p:sp>
+      <p:sp>
+        <p:nvSpPr>
+          <p:cNvPr id="3" name="Content Placeholder 2"/>
+          <p:cNvSpPr>
+            <a:spLocks noGrp="1"/>
+          </p:cNvSpPr>
+          <p:nvPr>
+            <p:ph idx="1"/>
+          </p:nvPr>
+        </p:nvSpPr>
+        <p:spPr/>
+        <p:txBody>
+          <a:bodyPr/>
+          <a:lstStyle/>
+          <a:p>
+            <a:pPr/>
+            <a:r>
+              <a:rPr b="1"/>
+              <a:t>두 방식은 서로 다른 비용을 낸다. 한 축만 보면 손익분기가 없다 (발표자 분석)</a:t>
+            </a:r>
+          </a:p>
+          <a:p>
+            <a:pPr lvl="1"/>
+            <a:r>
+              <a:rPr b="0"/>
+              <a:t>root 변경 빈도만 비교하면 λ_발급+λ_폐기(BAAR) ≥ λ_폐기(우리)라 우리가 항상 이긴다 — 그건 비교가 아니다</a:t>
+            </a:r>
+          </a:p>
+          <a:p>
+            <a:pPr/>
+            <a:r>
+              <a:rPr b="1"/>
+              <a:t>두 항으로 놓아야 갈림길이 보인다</a:t>
+            </a:r>
+          </a:p>
+          <a:p>
+            <a:pPr lvl="1"/>
+            <a:r>
+              <a:rPr b="0"/>
+              <a:t>BAAR가 더 내는 것:  (λ_발급 − λ_재기준화) × N_users × c_갱신   ← 폐기 게시는 양쪽 다 내므로 상쇄된다</a:t>
+            </a:r>
+          </a:p>
+          <a:p>
+            <a:pPr lvl="1"/>
+            <a:r>
+              <a:rPr b="0"/>
+              <a:t>우리가 더 내는 것:  λ_인증 × Δc_회로                          ← 인증 1회마다 붙는 비멤버십 비용</a:t>
+            </a:r>
+          </a:p>
+          <a:p>
+            <a:pPr lvl="1"/>
+            <a:r>
+              <a:rPr b="0"/>
+              <a:t>두 항은 단위가 다르므로 같은 척도(예: 사용자·단위시간당 지갑 CPU ms)로 환산해 비교해야 한다</a:t>
+            </a:r>
+          </a:p>
+          <a:p>
+            <a:pPr lvl="1"/>
+            <a:r>
+              <a:rPr b="0"/>
+              <a:t>손익분기는 그렇게 환산한 두 값이 같아지는 지점이다. N이 크고 발급이 잦을수록 BAAR 쪽이 커진다</a:t>
+            </a:r>
+          </a:p>
+          <a:p>
+            <a:pPr/>
+            <a:r>
+              <a:rPr b="1"/>
+              <a:t>우리 쪽 항의 크기 (우리 실측)</a:t>
+            </a:r>
+          </a:p>
+          <a:p>
+            <a:pPr lvl="1"/>
+            <a:r>
+              <a:rPr b="0"/>
+              <a:t>비멤버십 검증 1개 = 6,648 constraints. pi_pk_i는 세션·계정 두 번 인스턴스화한다 → 13,296</a:t>
+            </a:r>
+          </a:p>
+          <a:p>
+            <a:pPr lvl="1"/>
+            <a:r>
+              <a:rPr b="0"/>
+              <a:t>전체 19,251 중 69%가 폐기 확인 비용이다</a:t>
+            </a:r>
+          </a:p>
+          <a:p>
+            <a:pPr lvl="1"/>
+            <a:r>
+              <a:rPr b="1"/>
+              <a:t>단 constraints 69%가 시간 69%는 아니다 — 4,820 → 19,251(4.0배)일 때 295.5 → 755.8 ms(2.56배)다. 20번에서 BAAR를 때린 논리를 우리도 지켜야 한다</a:t>
+            </a:r>
+          </a:p>
+          <a:p>
+            <a:pPr/>
+            <a:r>
+              <a:rPr b="1"/>
+              <a:t>그래서: 우리는 세션마다 발급하므로(λ_발급 ≫ λ_폐기) BAAR 방식이면 갱신이 상시로 흐른다. 반대로 발급이 드문 환경이라면 회로 69%를 아끼는 BAAR 쪽이 낫다</a:t>
+            </a:r>
+          </a:p>
+        </p:txBody>
+      </p:sp>
+    </p:spTree>
+  </p:cSld>
+  <p:clrMapOvr>
+    <a:masterClrMapping/>
+  </p:clrMapOvr>
+</p:sld>
+</file>
+
+<file path=ppt/slides/slide24.xml><?xml version="1.0" encoding="utf-8"?>
 <p:sld xmlns:a="http://schemas.openxmlformats.org/drawingml/2006/main" xmlns:p="http://schemas.openxmlformats.org/presentationml/2006/main" xmlns:r="http://schemas.openxmlformats.org/officeDocument/2006/relationships">
   <p:cSld>
     <p:spTree>
@@ -7560,7 +7530,7 @@
 </p:sld>
 </file>
 
-<file path=ppt/slides/slide24.xml><?xml version="1.0" encoding="utf-8"?>
+<file path=ppt/slides/slide25.xml><?xml version="1.0" encoding="utf-8"?>
 <p:sld xmlns:a="http://schemas.openxmlformats.org/drawingml/2006/main" xmlns:p="http://schemas.openxmlformats.org/presentationml/2006/main" xmlns:r="http://schemas.openxmlformats.org/officeDocument/2006/relationships">
   <p:cSld>
     <p:spTree>
@@ -8113,124 +8083,6 @@
 </p:sld>
 </file>
 
-<file path=ppt/slides/slide25.xml><?xml version="1.0" encoding="utf-8"?>
-<p:sld xmlns:a="http://schemas.openxmlformats.org/drawingml/2006/main" xmlns:p="http://schemas.openxmlformats.org/presentationml/2006/main" xmlns:r="http://schemas.openxmlformats.org/officeDocument/2006/relationships">
-  <p:cSld>
-    <p:spTree>
-      <p:nvGrpSpPr>
-        <p:cNvPr id="1" name=""/>
-        <p:cNvGrpSpPr/>
-        <p:nvPr/>
-      </p:nvGrpSpPr>
-      <p:grpSpPr/>
-      <p:sp>
-        <p:nvSpPr>
-          <p:cNvPr id="2" name="Title 1"/>
-          <p:cNvSpPr>
-            <a:spLocks noGrp="1"/>
-          </p:cNvSpPr>
-          <p:nvPr>
-            <p:ph type="title"/>
-          </p:nvPr>
-        </p:nvSpPr>
-        <p:spPr/>
-        <p:txBody>
-          <a:bodyPr/>
-          <a:lstStyle/>
-          <a:p>
-            <a:r>
-              <a:t>우리가 지는 지점 — 즉시 폐기</a:t>
-            </a:r>
-          </a:p>
-        </p:txBody>
-      </p:sp>
-      <p:sp>
-        <p:nvSpPr>
-          <p:cNvPr id="3" name="Content Placeholder 2"/>
-          <p:cNvSpPr>
-            <a:spLocks noGrp="1"/>
-          </p:cNvSpPr>
-          <p:nvPr>
-            <p:ph idx="1"/>
-          </p:nvPr>
-        </p:nvSpPr>
-        <p:spPr/>
-        <p:txBody>
-          <a:bodyPr/>
-          <a:lstStyle/>
-          <a:p>
-            <a:pPr/>
-            <a:r>
-              <a:rPr b="1"/>
-              <a:t>BAAR: 리프를 빼는 순간 효력이 생긴다. 유예 창이 없다</a:t>
-            </a:r>
-          </a:p>
-          <a:p>
-            <a:pPr/>
-            <a:r>
-              <a:rPr b="1"/>
-              <a:t>우리: 폐기는 게시 주기가 지나야 효력이 생긴다</a:t>
-            </a:r>
-          </a:p>
-          <a:p>
-            <a:pPr lvl="1"/>
-            <a:r>
-              <a:rPr b="0"/>
-              <a:t>접수(pendingAdds) → prepare → 온체인 pushRoot → commit 의 2단계 게시를 거친다</a:t>
-            </a:r>
-          </a:p>
-          <a:p>
-            <a:pPr lvl="1"/>
-            <a:r>
-              <a:rPr b="0"/>
-              <a:t>그래서 "폐기 지연 = 게시 주기"이고, 주기를 줄이면 가스와 운영 부담이 는다</a:t>
-            </a:r>
-          </a:p>
-          <a:p>
-            <a:pPr/>
-            <a:r>
-              <a:rPr b="1"/>
-              <a:t>왜 그렇게 했는가 (발표자 분석)</a:t>
-            </a:r>
-          </a:p>
-          <a:p>
-            <a:pPr lvl="1"/>
-            <a:r>
-              <a:rPr b="0"/>
-              <a:t>온체인 게시가 확정되기 전에 IdP가 먼저 전진하면, 지갑이 만드는 witness의 root와 체인의 root가 어긋나 전원이 막힌다</a:t>
-            </a:r>
-          </a:p>
-          <a:p>
-            <a:pPr lvl="1"/>
-            <a:r>
-              <a:rPr b="0"/>
-              <a:t>그래서 push가 확정된 뒤에만 IdP가 전진하도록 prepare/commit으로 나눴다 — 원자성을 위해 지연을 산 것이다</a:t>
-            </a:r>
-          </a:p>
-          <a:p>
-            <a:pPr lvl="1"/>
-            <a:r>
-              <a:rPr b="0"/>
-              <a:t>폐기 하나마다 트랜잭션을 보내면 즉시성은 얻지만 가스와 실패 처리가 사이클마다 붙는다</a:t>
-            </a:r>
-          </a:p>
-          <a:p>
-            <a:pPr/>
-            <a:r>
-              <a:rPr b="1"/>
-              <a:t>논의거리: 즉시 폐기를 원한다면 우리는 무엇을 포기해야 하는가?</a:t>
-            </a:r>
-          </a:p>
-        </p:txBody>
-      </p:sp>
-    </p:spTree>
-  </p:cSld>
-  <p:clrMapOvr>
-    <a:masterClrMapping/>
-  </p:clrMapOvr>
-</p:sld>
-</file>
-
 <file path=ppt/slides/slide26.xml><?xml version="1.0" encoding="utf-8"?>
 <p:sld xmlns:a="http://schemas.openxmlformats.org/drawingml/2006/main" xmlns:p="http://schemas.openxmlformats.org/presentationml/2006/main" xmlns:r="http://schemas.openxmlformats.org/officeDocument/2006/relationships">
   <p:cSld>
@@ -8257,7 +8109,7 @@
           <a:lstStyle/>
           <a:p>
             <a:r>
-              <a:t>정리와 논의거리</a:t>
+              <a:t>우리가 지는 지점 — 즉시 폐기</a:t>
             </a:r>
           </a:p>
         </p:txBody>
@@ -8280,6 +8132,124 @@
             <a:pPr/>
             <a:r>
               <a:rPr b="1"/>
+              <a:t>BAAR: 리프를 빼는 순간 효력이 생긴다. 유예 창이 없다</a:t>
+            </a:r>
+          </a:p>
+          <a:p>
+            <a:pPr/>
+            <a:r>
+              <a:rPr b="1"/>
+              <a:t>우리: 폐기는 게시 주기가 지나야 효력이 생긴다</a:t>
+            </a:r>
+          </a:p>
+          <a:p>
+            <a:pPr lvl="1"/>
+            <a:r>
+              <a:rPr b="0"/>
+              <a:t>접수(pendingAdds) → prepare → 온체인 pushRoot → commit 의 2단계 게시를 거친다</a:t>
+            </a:r>
+          </a:p>
+          <a:p>
+            <a:pPr lvl="1"/>
+            <a:r>
+              <a:rPr b="0"/>
+              <a:t>그래서 "폐기 지연 = 게시 주기"이고, 주기를 줄이면 가스와 운영 부담이 는다</a:t>
+            </a:r>
+          </a:p>
+          <a:p>
+            <a:pPr/>
+            <a:r>
+              <a:rPr b="1"/>
+              <a:t>왜 그렇게 했는가 (발표자 분석)</a:t>
+            </a:r>
+          </a:p>
+          <a:p>
+            <a:pPr lvl="1"/>
+            <a:r>
+              <a:rPr b="0"/>
+              <a:t>온체인 게시가 확정되기 전에 IdP가 먼저 전진하면, 지갑이 만드는 witness의 root와 체인의 root가 어긋나 전원이 막힌다</a:t>
+            </a:r>
+          </a:p>
+          <a:p>
+            <a:pPr lvl="1"/>
+            <a:r>
+              <a:rPr b="0"/>
+              <a:t>그래서 push가 확정된 뒤에만 IdP가 전진하도록 prepare/commit으로 나눴다 — 원자성을 위해 지연을 산 것이다</a:t>
+            </a:r>
+          </a:p>
+          <a:p>
+            <a:pPr lvl="1"/>
+            <a:r>
+              <a:rPr b="0"/>
+              <a:t>폐기 하나마다 트랜잭션을 보내면 즉시성은 얻지만 가스와 실패 처리가 사이클마다 붙는다</a:t>
+            </a:r>
+          </a:p>
+          <a:p>
+            <a:pPr/>
+            <a:r>
+              <a:rPr b="1"/>
+              <a:t>논의거리: 즉시 폐기를 원한다면 우리는 무엇을 포기해야 하는가?</a:t>
+            </a:r>
+          </a:p>
+        </p:txBody>
+      </p:sp>
+    </p:spTree>
+  </p:cSld>
+  <p:clrMapOvr>
+    <a:masterClrMapping/>
+  </p:clrMapOvr>
+</p:sld>
+</file>
+
+<file path=ppt/slides/slide27.xml><?xml version="1.0" encoding="utf-8"?>
+<p:sld xmlns:a="http://schemas.openxmlformats.org/drawingml/2006/main" xmlns:p="http://schemas.openxmlformats.org/presentationml/2006/main" xmlns:r="http://schemas.openxmlformats.org/officeDocument/2006/relationships">
+  <p:cSld>
+    <p:spTree>
+      <p:nvGrpSpPr>
+        <p:cNvPr id="1" name=""/>
+        <p:cNvGrpSpPr/>
+        <p:nvPr/>
+      </p:nvGrpSpPr>
+      <p:grpSpPr/>
+      <p:sp>
+        <p:nvSpPr>
+          <p:cNvPr id="2" name="Title 1"/>
+          <p:cNvSpPr>
+            <a:spLocks noGrp="1"/>
+          </p:cNvSpPr>
+          <p:nvPr>
+            <p:ph type="title"/>
+          </p:nvPr>
+        </p:nvSpPr>
+        <p:spPr/>
+        <p:txBody>
+          <a:bodyPr/>
+          <a:lstStyle/>
+          <a:p>
+            <a:r>
+              <a:t>정리와 논의거리</a:t>
+            </a:r>
+          </a:p>
+        </p:txBody>
+      </p:sp>
+      <p:sp>
+        <p:nvSpPr>
+          <p:cNvPr id="3" name="Content Placeholder 2"/>
+          <p:cNvSpPr>
+            <a:spLocks noGrp="1"/>
+          </p:cNvSpPr>
+          <p:nvPr>
+            <p:ph idx="1"/>
+          </p:nvPr>
+        </p:nvSpPr>
+        <p:spPr/>
+        <p:txBody>
+          <a:bodyPr/>
+          <a:lstStyle/>
+          <a:p>
+            <a:pPr/>
+            <a:r>
+              <a:rPr b="1"/>
               <a:t>이 논문이 잘한 것</a:t>
             </a:r>
           </a:p>
@@ -8322,14 +8292,14 @@
             <a:pPr lvl="1"/>
             <a:r>
               <a:rPr b="0"/>
-              <a:t>witness 갱신의 전달 채널이 설계·평가 어디에도 없다 — CIA 상시 의존이 숨어 있다(21번)</a:t>
+              <a:t>witness 갱신의 전달 채널이 설계·평가 어디에도 없다 — CIA 상시 의존이 숨어 있다(22번)</a:t>
             </a:r>
           </a:p>
           <a:p>
             <a:pPr lvl="1"/>
             <a:r>
               <a:rPr b="1"/>
-              <a:t>unlinkability 주장과 프로토콜이 어긋난다 — C와 witness를 평문으로 넘기므로 검증자 하나로 세션 연결이 된다(15번)</a:t>
+              <a:t>unlinkability 주장과 프로토콜이 어긋난다 — C와 witness를 평문으로 넘기므로 검증자 하나로 세션 연결이 된다(16번)</a:t>
             </a:r>
           </a:p>
           <a:p>
@@ -8614,7 +8584,7 @@
             <a:pPr lvl="1"/>
             <a:r>
               <a:rPr b="0"/>
-              <a:t>그래서 SNARK가 아니라 Schnorr Σ-protocol을 고른다 — 23번에서 이 선택의 대가를 본다</a:t>
+              <a:t>그래서 SNARK가 아니라 Schnorr Σ-protocol을 고른다 — 24번에서 이 선택의 대가를 본다</a:t>
             </a:r>
           </a:p>
         </p:txBody>
@@ -9240,7 +9210,7 @@
             </a:pPr>
             <a:r>
               <a:rPr b="0" sz="1200"/>
-              <a:t>발표자 분석: 검증자가 오프체인 주체라는 점을 기억해 두자. 우리 시스템은 검증자가 스마트컨트랙트다 — 23번에서 이 차이가 결정적으로 작동한다.</a:t>
+              <a:t>발표자 분석: 검증자가 오프체인 주체라는 점을 기억해 두자. 우리 시스템은 검증자가 스마트컨트랙트다 — 24번에서 이 차이가 결정적으로 작동한다.</a:t>
             </a:r>
           </a:p>
           <a:p>
@@ -9374,7 +9344,7 @@
             <a:pPr lvl="1"/>
             <a:r>
               <a:rPr b="1"/>
-              <a:t>증명 비용은 생성원 개수, 즉 속성 수 n에 선형이다 — 19번의 sublinear 주장과 충돌한다</a:t>
+              <a:t>증명 비용은 생성원 개수, 즉 속성 수 n에 선형이다 — 20번의 sublinear 비판과 이어진다</a:t>
             </a:r>
           </a:p>
         </p:txBody>
@@ -9471,7 +9441,7 @@
             <a:pPr lvl="1"/>
             <a:r>
               <a:rPr b="1"/>
-              <a:t>개별 커밋먼트는 체인에 저장하지 않는다 — 가스가 낮은 이유이자, 21번 비판의 뿌리다</a:t>
+              <a:t>개별 커밋먼트는 체인에 저장하지 않는다 — 가스가 낮은 이유이자, 22번 비판의 뿌리다</a:t>
             </a:r>
           </a:p>
           <a:p>

</xml_diff>